<commit_message>
Add Grade 1 Bunny's Reading Adventure deck (60 min, 30 slides) and tighten deck layout checks.
Co-authored-by: Cursor <cursoragent@cursor.com>
</commit_message>
<xml_diff>
--- a/Grade2_Bear_Reading_Adventure_90min.pptx
+++ b/Grade2_Bear_Reading_Adventure_90min.pptx
@@ -8760,7 +8760,7 @@
         <p:spPr>
           <a:xfrm>
             <a:off x="365760" y="731520"/>
-            <a:ext cx="11338560" cy="548640"/>
+            <a:ext cx="11338560" cy="457200"/>
           </a:xfrm>
           <a:prstGeom prst="rect">
             <a:avLst/>
@@ -10820,7 +10820,7 @@
         <p:spPr>
           <a:xfrm>
             <a:off x="365760" y="731520"/>
-            <a:ext cx="11338560" cy="548640"/>
+            <a:ext cx="11338560" cy="457200"/>
           </a:xfrm>
           <a:prstGeom prst="rect">
             <a:avLst/>
@@ -12888,7 +12888,7 @@
         <p:spPr>
           <a:xfrm>
             <a:off x="365760" y="731520"/>
-            <a:ext cx="11338560" cy="548640"/>
+            <a:ext cx="11338560" cy="457200"/>
           </a:xfrm>
           <a:prstGeom prst="rect">
             <a:avLst/>
@@ -14563,7 +14563,7 @@
         <p:spPr>
           <a:xfrm>
             <a:off x="365760" y="731520"/>
-            <a:ext cx="11338560" cy="548640"/>
+            <a:ext cx="11338560" cy="457200"/>
           </a:xfrm>
           <a:prstGeom prst="rect">
             <a:avLst/>
@@ -16967,7 +16967,7 @@
         <p:spPr>
           <a:xfrm>
             <a:off x="365760" y="731520"/>
-            <a:ext cx="11338560" cy="548640"/>
+            <a:ext cx="11338560" cy="457200"/>
           </a:xfrm>
           <a:prstGeom prst="rect">
             <a:avLst/>
@@ -18158,7 +18158,7 @@
         <p:spPr>
           <a:xfrm>
             <a:off x="365760" y="731520"/>
-            <a:ext cx="11338560" cy="548640"/>
+            <a:ext cx="11338560" cy="457200"/>
           </a:xfrm>
           <a:prstGeom prst="rect">
             <a:avLst/>
@@ -19411,7 +19411,7 @@
         <p:spPr>
           <a:xfrm>
             <a:off x="365760" y="731520"/>
-            <a:ext cx="11338560" cy="548640"/>
+            <a:ext cx="11338560" cy="457200"/>
           </a:xfrm>
           <a:prstGeom prst="rect">
             <a:avLst/>
@@ -20500,7 +20500,7 @@
         <p:spPr>
           <a:xfrm>
             <a:off x="365760" y="731520"/>
-            <a:ext cx="11338560" cy="548640"/>
+            <a:ext cx="11338560" cy="457200"/>
           </a:xfrm>
           <a:prstGeom prst="rect">
             <a:avLst/>
@@ -21379,7 +21379,7 @@
         <p:spPr>
           <a:xfrm>
             <a:off x="365760" y="731520"/>
-            <a:ext cx="11338560" cy="548640"/>
+            <a:ext cx="11338560" cy="457200"/>
           </a:xfrm>
           <a:prstGeom prst="rect">
             <a:avLst/>
@@ -22258,7 +22258,7 @@
         <p:spPr>
           <a:xfrm>
             <a:off x="365760" y="731520"/>
-            <a:ext cx="11338560" cy="548640"/>
+            <a:ext cx="11338560" cy="457200"/>
           </a:xfrm>
           <a:prstGeom prst="rect">
             <a:avLst/>
@@ -24116,7 +24116,7 @@
         <p:spPr>
           <a:xfrm>
             <a:off x="365760" y="731520"/>
-            <a:ext cx="11338560" cy="548640"/>
+            <a:ext cx="11338560" cy="457200"/>
           </a:xfrm>
           <a:prstGeom prst="rect">
             <a:avLst/>
@@ -26176,7 +26176,7 @@
         <p:spPr>
           <a:xfrm>
             <a:off x="365760" y="731520"/>
-            <a:ext cx="11338560" cy="548640"/>
+            <a:ext cx="11338560" cy="457200"/>
           </a:xfrm>
           <a:prstGeom prst="rect">
             <a:avLst/>
@@ -28190,7 +28190,7 @@
         <p:spPr>
           <a:xfrm>
             <a:off x="365760" y="731520"/>
-            <a:ext cx="11338560" cy="548640"/>
+            <a:ext cx="11338560" cy="457200"/>
           </a:xfrm>
           <a:prstGeom prst="rect">
             <a:avLst/>
@@ -30530,7 +30530,7 @@
         <p:spPr>
           <a:xfrm>
             <a:off x="365760" y="731520"/>
-            <a:ext cx="11338560" cy="548640"/>
+            <a:ext cx="11338560" cy="457200"/>
           </a:xfrm>
           <a:prstGeom prst="rect">
             <a:avLst/>
@@ -31522,7 +31522,7 @@
         <p:spPr>
           <a:xfrm>
             <a:off x="365760" y="731520"/>
-            <a:ext cx="11338560" cy="548640"/>
+            <a:ext cx="11338560" cy="457200"/>
           </a:xfrm>
           <a:prstGeom prst="rect">
             <a:avLst/>
@@ -32514,7 +32514,7 @@
         <p:spPr>
           <a:xfrm>
             <a:off x="365760" y="731520"/>
-            <a:ext cx="11338560" cy="548640"/>
+            <a:ext cx="11338560" cy="457200"/>
           </a:xfrm>
           <a:prstGeom prst="rect">
             <a:avLst/>
@@ -33506,7 +33506,7 @@
         <p:spPr>
           <a:xfrm>
             <a:off x="365760" y="731520"/>
-            <a:ext cx="11338560" cy="548640"/>
+            <a:ext cx="11338560" cy="457200"/>
           </a:xfrm>
           <a:prstGeom prst="rect">
             <a:avLst/>
@@ -34498,7 +34498,7 @@
         <p:spPr>
           <a:xfrm>
             <a:off x="365760" y="731520"/>
-            <a:ext cx="11338560" cy="548640"/>
+            <a:ext cx="11338560" cy="457200"/>
           </a:xfrm>
           <a:prstGeom prst="rect">
             <a:avLst/>
@@ -35533,7 +35533,7 @@
         <p:spPr>
           <a:xfrm>
             <a:off x="365760" y="731520"/>
-            <a:ext cx="11338560" cy="548640"/>
+            <a:ext cx="11338560" cy="457200"/>
           </a:xfrm>
           <a:prstGeom prst="rect">
             <a:avLst/>
@@ -37515,7 +37515,7 @@
         <p:spPr>
           <a:xfrm>
             <a:off x="365760" y="731520"/>
-            <a:ext cx="11338560" cy="548640"/>
+            <a:ext cx="11338560" cy="457200"/>
           </a:xfrm>
           <a:prstGeom prst="rect">
             <a:avLst/>
@@ -39131,7 +39131,7 @@
         <p:spPr>
           <a:xfrm>
             <a:off x="365760" y="731520"/>
-            <a:ext cx="11338560" cy="548640"/>
+            <a:ext cx="11338560" cy="457200"/>
           </a:xfrm>
           <a:prstGeom prst="rect">
             <a:avLst/>
@@ -40521,7 +40521,7 @@
         <p:spPr>
           <a:xfrm>
             <a:off x="365760" y="731520"/>
-            <a:ext cx="11338560" cy="548640"/>
+            <a:ext cx="11338560" cy="457200"/>
           </a:xfrm>
           <a:prstGeom prst="rect">
             <a:avLst/>
@@ -41922,7 +41922,7 @@
         <p:spPr>
           <a:xfrm>
             <a:off x="365760" y="731520"/>
-            <a:ext cx="11338560" cy="548640"/>
+            <a:ext cx="11338560" cy="457200"/>
           </a:xfrm>
           <a:prstGeom prst="rect">
             <a:avLst/>
@@ -43600,7 +43600,7 @@
         <p:spPr>
           <a:xfrm>
             <a:off x="365760" y="731520"/>
-            <a:ext cx="11338560" cy="548640"/>
+            <a:ext cx="11338560" cy="457200"/>
           </a:xfrm>
           <a:prstGeom prst="rect">
             <a:avLst/>
@@ -45998,7 +45998,7 @@
         <p:spPr>
           <a:xfrm>
             <a:off x="365760" y="731520"/>
-            <a:ext cx="11338560" cy="548640"/>
+            <a:ext cx="11338560" cy="457200"/>
           </a:xfrm>
           <a:prstGeom prst="rect">
             <a:avLst/>
@@ -47528,7 +47528,7 @@
         <p:spPr>
           <a:xfrm>
             <a:off x="365760" y="731520"/>
-            <a:ext cx="11338560" cy="548640"/>
+            <a:ext cx="11338560" cy="457200"/>
           </a:xfrm>
           <a:prstGeom prst="rect">
             <a:avLst/>
@@ -47761,7 +47761,7 @@
         </p:nvSpPr>
         <p:spPr>
           <a:xfrm>
-            <a:off x="411480" y="1188720"/>
+            <a:off x="411480" y="1225296"/>
             <a:ext cx="11338560" cy="320040"/>
           </a:xfrm>
           <a:prstGeom prst="rect">
@@ -50007,7 +50007,7 @@
         <p:spPr>
           <a:xfrm>
             <a:off x="365760" y="731520"/>
-            <a:ext cx="11338560" cy="548640"/>
+            <a:ext cx="11338560" cy="457200"/>
           </a:xfrm>
           <a:prstGeom prst="rect">
             <a:avLst/>
@@ -50240,7 +50240,7 @@
         </p:nvSpPr>
         <p:spPr>
           <a:xfrm>
-            <a:off x="411480" y="1170432"/>
+            <a:off x="411480" y="1225296"/>
             <a:ext cx="11338560" cy="320040"/>
           </a:xfrm>
           <a:prstGeom prst="rect">
@@ -51013,7 +51013,7 @@
         <p:spPr>
           <a:xfrm>
             <a:off x="365760" y="731520"/>
-            <a:ext cx="11338560" cy="548640"/>
+            <a:ext cx="11338560" cy="457200"/>
           </a:xfrm>
           <a:prstGeom prst="rect">
             <a:avLst/>
@@ -53353,7 +53353,7 @@
         <p:spPr>
           <a:xfrm>
             <a:off x="365760" y="731520"/>
-            <a:ext cx="11338560" cy="548640"/>
+            <a:ext cx="11338560" cy="457200"/>
           </a:xfrm>
           <a:prstGeom prst="rect">
             <a:avLst/>
@@ -54961,7 +54961,7 @@
         <p:spPr>
           <a:xfrm>
             <a:off x="365760" y="731520"/>
-            <a:ext cx="11338560" cy="548640"/>
+            <a:ext cx="11338560" cy="457200"/>
           </a:xfrm>
           <a:prstGeom prst="rect">
             <a:avLst/>
@@ -56927,7 +56927,7 @@
         <p:spPr>
           <a:xfrm>
             <a:off x="365760" y="731520"/>
-            <a:ext cx="11338560" cy="548640"/>
+            <a:ext cx="11338560" cy="457200"/>
           </a:xfrm>
           <a:prstGeom prst="rect">
             <a:avLst/>
@@ -58503,7 +58503,7 @@
         <p:spPr>
           <a:xfrm>
             <a:off x="365760" y="731520"/>
-            <a:ext cx="11338560" cy="548640"/>
+            <a:ext cx="11338560" cy="457200"/>
           </a:xfrm>
           <a:prstGeom prst="rect">
             <a:avLst/>
@@ -61467,7 +61467,7 @@
         <p:spPr>
           <a:xfrm>
             <a:off x="365760" y="731520"/>
-            <a:ext cx="11338560" cy="548640"/>
+            <a:ext cx="11338560" cy="457200"/>
           </a:xfrm>
           <a:prstGeom prst="rect">
             <a:avLst/>

</xml_diff>